<commit_message>
docs: drop the web-app merge row from the deck's schedule slide
</commit_message>
<xml_diff>
--- a/docs/obi-e2e-onboarding.pptx
+++ b/docs/obi-e2e-onboarding.pptx
@@ -1618,7 +1618,7 @@
           <a:p>
             <a:r>
               <a:rPr lang="en-US" dirty="0"/>
-              <a:t>Every morning at 08:00 Swiss time both suites run on staging, and when the web app releases both suites run on staging in a Teams thread named after the release. A merge to this repository’s main runs both suites on the preview, which is the web app’s main branch on the staging backend; a merge to the web app’s main runs the regular suite there once that build is live. A manual run picks its deployment, and ticking “slow” adds the slow suite to the same thread; today it is the only way to run on production. At the same time Lighthouse measures the public website’s speed on staging and production. Each run gets its own Teams thread and its own report folder, and runs never cancel each other.</a:t>
+              <a:t>Every morning at 08:00 Swiss time both suites run on staging, and when the web app releases both suites run on staging in a Teams thread named after the release. A merge to this repository’s main runs both suites on the preview, which is the web app’s main branch on the staging backend. A manual run picks its deployment, and ticking “slow” adds the slow suite to the same thread; today it is the only way to run on production. At the same time Lighthouse measures the public website’s speed on staging and production. Each run gets its own Teams thread and its own report folder, and runs never cancel each other.</a:t>
             </a:r>
             <a:endParaRPr lang="en-US" dirty="0"/>
           </a:p>
@@ -15758,173 +15758,13 @@
       </p:sp>
       <p:sp>
         <p:nvSpPr>
-          <p:cNvPr id="32" name="node-137"/>
-          <p:cNvSpPr/>
-          <p:nvPr/>
-        </p:nvSpPr>
-        <p:spPr>
-          <a:xfrm>
-            <a:off x="713232" y="4041648"/>
-            <a:ext cx="402336" cy="402336"/>
-          </a:xfrm>
-          <a:prstGeom prst="ellipse">
-            <a:avLst/>
-          </a:prstGeom>
-          <a:solidFill>
-            <a:schemeClr val="tx1"/>
-          </a:solidFill>
-          <a:ln/>
-        </p:spPr>
-      </p:sp>
-      <p:pic>
-        <p:nvPicPr>
-          <p:cNvPr id="33" name="icon-138" descr="preencoded.png">    </p:cNvPr>
-          <p:cNvPicPr>
-            <a:picLocks noChangeAspect="1"/>
-          </p:cNvPicPr>
-          <p:nvPr/>
-        </p:nvPicPr>
-        <p:blipFill>
-          <a:blip r:embed="rId4"/>
-          <a:stretch>
-            <a:fillRect/>
-          </a:stretch>
-        </p:blipFill>
-        <p:spPr>
-          <a:xfrm>
-            <a:off x="813816" y="4142232"/>
-            <a:ext cx="201168" cy="201168"/>
-          </a:xfrm>
-          <a:prstGeom prst="rect">
-            <a:avLst/>
-          </a:prstGeom>
-        </p:spPr>
-      </p:pic>
-      <p:sp>
-        <p:nvSpPr>
-          <p:cNvPr id="34" name="text-139"/>
-          <p:cNvSpPr txBox="1"/>
-          <p:nvPr/>
-        </p:nvSpPr>
-        <p:spPr>
-          <a:xfrm>
-            <a:off x="1325880" y="3968496"/>
-            <a:ext cx="2743200" cy="548640"/>
-          </a:xfrm>
-          <a:prstGeom prst="rect">
-            <a:avLst/>
-          </a:prstGeom>
-          <a:noFill/>
-          <a:ln/>
-        </p:spPr>
-        <p:txBody>
-          <a:bodyPr wrap="square" lIns="0" tIns="0" rIns="0" bIns="0" rtlCol="0" anchor="ctr"/>
-          <a:lstStyle/>
-          <a:p>
-            <a:pPr indent="0" marL="0">
-              <a:buNone/>
-            </a:pPr>
-            <a:r>
-              <a:rPr lang="en-US" sz="1600" b="1" dirty="0">
-                <a:solidFill>
-                  <a:schemeClr val="tx1"/>
-                </a:solidFill>
-              </a:rPr>
-              <a:t>Merge to web-app main</a:t>
-            </a:r>
-            <a:endParaRPr lang="en-US" sz="1600" dirty="0"/>
-          </a:p>
-        </p:txBody>
-      </p:sp>
-      <p:sp>
-        <p:nvSpPr>
-          <p:cNvPr id="35" name="card-140"/>
-          <p:cNvSpPr/>
-          <p:nvPr/>
-        </p:nvSpPr>
-        <p:spPr>
-          <a:xfrm>
-            <a:off x="4160520" y="4078224"/>
-            <a:ext cx="914400" cy="329184"/>
-          </a:xfrm>
-          <a:prstGeom prst="roundRect">
-            <a:avLst>
-              <a:gd name="adj" fmla="val 50000"/>
-            </a:avLst>
-          </a:prstGeom>
-          <a:solidFill>
-            <a:schemeClr val="accent1"/>
-          </a:solidFill>
-          <a:ln/>
-        </p:spPr>
-      </p:sp>
-      <p:sp>
-        <p:nvSpPr>
-          <p:cNvPr id="36" name="text-141"/>
-          <p:cNvSpPr txBox="1"/>
-          <p:nvPr/>
-        </p:nvSpPr>
-        <p:spPr>
-          <a:xfrm>
-            <a:off x="4160520" y="4078224"/>
-            <a:ext cx="914400" cy="329184"/>
-          </a:xfrm>
-          <a:prstGeom prst="rect">
-            <a:avLst/>
-          </a:prstGeom>
-          <a:noFill/>
-          <a:ln/>
-        </p:spPr>
-        <p:txBody>
-          <a:bodyPr wrap="square" lIns="0" tIns="0" rIns="0" bIns="0" rtlCol="0" anchor="ctr"/>
-          <a:lstStyle/>
-          <a:p>
-            <a:pPr algn="ctr" indent="0" marL="0">
-              <a:buNone/>
-            </a:pPr>
-            <a:r>
-              <a:rPr lang="en-US" sz="1200" b="1" dirty="0">
-                <a:solidFill>
-                  <a:schemeClr val="bg1"/>
-                </a:solidFill>
-              </a:rPr>
-              <a:t>Regular</a:t>
-            </a:r>
-            <a:endParaRPr lang="en-US" sz="1200" dirty="0"/>
-          </a:p>
-        </p:txBody>
-      </p:sp>
-      <p:sp>
-        <p:nvSpPr>
-          <p:cNvPr id="37" name="card-142"/>
-          <p:cNvSpPr/>
-          <p:nvPr/>
-        </p:nvSpPr>
-        <p:spPr>
-          <a:xfrm>
-            <a:off x="548640" y="4590288"/>
-            <a:ext cx="11091672" cy="548640"/>
-          </a:xfrm>
-          <a:prstGeom prst="roundRect">
-            <a:avLst>
-              <a:gd name="adj" fmla="val 13333"/>
-            </a:avLst>
-          </a:prstGeom>
-          <a:solidFill>
-            <a:schemeClr val="bg2"/>
-          </a:solidFill>
-          <a:ln/>
-        </p:spPr>
-      </p:sp>
-      <p:sp>
-        <p:nvSpPr>
           <p:cNvPr id="38" name="node-143"/>
           <p:cNvSpPr/>
           <p:nvPr/>
         </p:nvSpPr>
         <p:spPr>
           <a:xfrm>
-            <a:off x="713232" y="4663440"/>
+            <a:off x="713232" y="4041648"/>
             <a:ext cx="402336" cy="402336"/>
           </a:xfrm>
           <a:prstGeom prst="ellipse">
@@ -15952,7 +15792,7 @@
         </p:blipFill>
         <p:spPr>
           <a:xfrm>
-            <a:off x="813816" y="4764024"/>
+            <a:off x="813816" y="4142232"/>
             <a:ext cx="201168" cy="201168"/>
           </a:xfrm>
           <a:prstGeom prst="rect">
@@ -15968,7 +15808,7 @@
         </p:nvSpPr>
         <p:spPr>
           <a:xfrm>
-            <a:off x="1325880" y="4590288"/>
+            <a:off x="1325880" y="3968496"/>
             <a:ext cx="2743200" cy="548640"/>
           </a:xfrm>
           <a:prstGeom prst="rect">
@@ -16004,7 +15844,7 @@
         </p:nvSpPr>
         <p:spPr>
           <a:xfrm>
-            <a:off x="4160520" y="4700016"/>
+            <a:off x="4160520" y="4078224"/>
             <a:ext cx="1005840" cy="329184"/>
           </a:xfrm>
           <a:prstGeom prst="roundRect">
@@ -16031,7 +15871,7 @@
         </p:nvSpPr>
         <p:spPr>
           <a:xfrm>
-            <a:off x="4160520" y="4700016"/>
+            <a:off x="4160520" y="4078224"/>
             <a:ext cx="1005840" cy="329184"/>
           </a:xfrm>
           <a:prstGeom prst="rect">
@@ -16067,7 +15907,7 @@
         </p:nvSpPr>
         <p:spPr>
           <a:xfrm>
-            <a:off x="6675120" y="4700016"/>
+            <a:off x="6675120" y="4078224"/>
             <a:ext cx="1005840" cy="329184"/>
           </a:xfrm>
           <a:prstGeom prst="roundRect">
@@ -16094,7 +15934,7 @@
         </p:nvSpPr>
         <p:spPr>
           <a:xfrm>
-            <a:off x="6675120" y="4700016"/>
+            <a:off x="6675120" y="4078224"/>
             <a:ext cx="1005840" cy="329184"/>
           </a:xfrm>
           <a:prstGeom prst="rect">
@@ -16130,7 +15970,7 @@
         </p:nvSpPr>
         <p:spPr>
           <a:xfrm>
-            <a:off x="9189720" y="4700016"/>
+            <a:off x="9189720" y="4078224"/>
             <a:ext cx="1005840" cy="329184"/>
           </a:xfrm>
           <a:prstGeom prst="roundRect">
@@ -16157,7 +15997,7 @@
         </p:nvSpPr>
         <p:spPr>
           <a:xfrm>
-            <a:off x="9189720" y="4700016"/>
+            <a:off x="9189720" y="4078224"/>
             <a:ext cx="1005840" cy="329184"/>
           </a:xfrm>
           <a:prstGeom prst="rect">
@@ -16184,6 +16024,28 @@
             <a:endParaRPr lang="en-US" sz="1200" dirty="0"/>
           </a:p>
         </p:txBody>
+      </p:sp>
+      <p:sp>
+        <p:nvSpPr>
+          <p:cNvPr id="55" name="card-band"/>
+          <p:cNvSpPr/>
+          <p:nvPr/>
+        </p:nvSpPr>
+        <p:spPr>
+          <a:xfrm>
+            <a:off x="548640" y="4590288"/>
+            <a:ext cx="11091672" cy="548640"/>
+          </a:xfrm>
+          <a:prstGeom prst="roundRect">
+            <a:avLst>
+              <a:gd name="adj" fmla="val 13333"/>
+            </a:avLst>
+          </a:prstGeom>
+          <a:solidFill>
+            <a:schemeClr val="bg2"/>
+          </a:solidFill>
+          <a:ln/>
+        </p:spPr>
       </p:sp>
       <p:sp>
         <p:nvSpPr>
@@ -16193,7 +16055,7 @@
         </p:nvSpPr>
         <p:spPr>
           <a:xfrm>
-            <a:off x="713232" y="5285232"/>
+            <a:off x="713232" y="4663440"/>
             <a:ext cx="402336" cy="402336"/>
           </a:xfrm>
           <a:prstGeom prst="ellipse">
@@ -16221,7 +16083,7 @@
         </p:blipFill>
         <p:spPr>
           <a:xfrm>
-            <a:off x="813816" y="5385816"/>
+            <a:off x="813816" y="4764024"/>
             <a:ext cx="201168" cy="201168"/>
           </a:xfrm>
           <a:prstGeom prst="rect">
@@ -16237,7 +16099,7 @@
         </p:nvSpPr>
         <p:spPr>
           <a:xfrm>
-            <a:off x="1325880" y="5212080"/>
+            <a:off x="1325880" y="4590288"/>
             <a:ext cx="2743200" cy="548640"/>
           </a:xfrm>
           <a:prstGeom prst="rect">
@@ -16273,7 +16135,7 @@
         </p:nvSpPr>
         <p:spPr>
           <a:xfrm>
-            <a:off x="6675120" y="5321808"/>
+            <a:off x="6675120" y="4700016"/>
             <a:ext cx="1371600" cy="329184"/>
           </a:xfrm>
           <a:prstGeom prst="roundRect">
@@ -16295,7 +16157,7 @@
         </p:nvSpPr>
         <p:spPr>
           <a:xfrm>
-            <a:off x="6675120" y="5321808"/>
+            <a:off x="6675120" y="4700016"/>
             <a:ext cx="1371600" cy="329184"/>
           </a:xfrm>
           <a:prstGeom prst="rect">
@@ -16331,7 +16193,7 @@
         </p:nvSpPr>
         <p:spPr>
           <a:xfrm>
-            <a:off x="9189720" y="5321808"/>
+            <a:off x="9189720" y="4700016"/>
             <a:ext cx="1371600" cy="329184"/>
           </a:xfrm>
           <a:prstGeom prst="roundRect">
@@ -16353,7 +16215,7 @@
         </p:nvSpPr>
         <p:spPr>
           <a:xfrm>
-            <a:off x="9189720" y="5321808"/>
+            <a:off x="9189720" y="4700016"/>
             <a:ext cx="1371600" cy="329184"/>
           </a:xfrm>
           <a:prstGeom prst="rect">
@@ -16389,7 +16251,7 @@
         </p:nvSpPr>
         <p:spPr>
           <a:xfrm>
-            <a:off x="548640" y="5870448"/>
+            <a:off x="548640" y="5440680"/>
             <a:ext cx="10972800" cy="320040"/>
           </a:xfrm>
           <a:prstGeom prst="rect">

</xml_diff>

<commit_message>
docs: drop the web-app merge row from the deck's schedule slide (#39)
</commit_message>
<xml_diff>
--- a/docs/obi-e2e-onboarding.pptx
+++ b/docs/obi-e2e-onboarding.pptx
@@ -1618,7 +1618,7 @@
           <a:p>
             <a:r>
               <a:rPr lang="en-US" dirty="0"/>
-              <a:t>Every morning at 08:00 Swiss time both suites run on staging, and when the web app releases both suites run on staging in a Teams thread named after the release. A merge to this repository’s main runs both suites on the preview, which is the web app’s main branch on the staging backend; a merge to the web app’s main runs the regular suite there once that build is live. A manual run picks its deployment, and ticking “slow” adds the slow suite to the same thread; today it is the only way to run on production. At the same time Lighthouse measures the public website’s speed on staging and production. Each run gets its own Teams thread and its own report folder, and runs never cancel each other.</a:t>
+              <a:t>Every morning at 08:00 Swiss time both suites run on staging, and when the web app releases both suites run on staging in a Teams thread named after the release. A merge to this repository’s main runs both suites on the preview, which is the web app’s main branch on the staging backend. A manual run picks its deployment, and ticking “slow” adds the slow suite to the same thread; today it is the only way to run on production. At the same time Lighthouse measures the public website’s speed on staging and production. Each run gets its own Teams thread and its own report folder, and runs never cancel each other.</a:t>
             </a:r>
             <a:endParaRPr lang="en-US" dirty="0"/>
           </a:p>
@@ -15758,173 +15758,13 @@
       </p:sp>
       <p:sp>
         <p:nvSpPr>
-          <p:cNvPr id="32" name="node-137"/>
-          <p:cNvSpPr/>
-          <p:nvPr/>
-        </p:nvSpPr>
-        <p:spPr>
-          <a:xfrm>
-            <a:off x="713232" y="4041648"/>
-            <a:ext cx="402336" cy="402336"/>
-          </a:xfrm>
-          <a:prstGeom prst="ellipse">
-            <a:avLst/>
-          </a:prstGeom>
-          <a:solidFill>
-            <a:schemeClr val="tx1"/>
-          </a:solidFill>
-          <a:ln/>
-        </p:spPr>
-      </p:sp>
-      <p:pic>
-        <p:nvPicPr>
-          <p:cNvPr id="33" name="icon-138" descr="preencoded.png">    </p:cNvPr>
-          <p:cNvPicPr>
-            <a:picLocks noChangeAspect="1"/>
-          </p:cNvPicPr>
-          <p:nvPr/>
-        </p:nvPicPr>
-        <p:blipFill>
-          <a:blip r:embed="rId4"/>
-          <a:stretch>
-            <a:fillRect/>
-          </a:stretch>
-        </p:blipFill>
-        <p:spPr>
-          <a:xfrm>
-            <a:off x="813816" y="4142232"/>
-            <a:ext cx="201168" cy="201168"/>
-          </a:xfrm>
-          <a:prstGeom prst="rect">
-            <a:avLst/>
-          </a:prstGeom>
-        </p:spPr>
-      </p:pic>
-      <p:sp>
-        <p:nvSpPr>
-          <p:cNvPr id="34" name="text-139"/>
-          <p:cNvSpPr txBox="1"/>
-          <p:nvPr/>
-        </p:nvSpPr>
-        <p:spPr>
-          <a:xfrm>
-            <a:off x="1325880" y="3968496"/>
-            <a:ext cx="2743200" cy="548640"/>
-          </a:xfrm>
-          <a:prstGeom prst="rect">
-            <a:avLst/>
-          </a:prstGeom>
-          <a:noFill/>
-          <a:ln/>
-        </p:spPr>
-        <p:txBody>
-          <a:bodyPr wrap="square" lIns="0" tIns="0" rIns="0" bIns="0" rtlCol="0" anchor="ctr"/>
-          <a:lstStyle/>
-          <a:p>
-            <a:pPr indent="0" marL="0">
-              <a:buNone/>
-            </a:pPr>
-            <a:r>
-              <a:rPr lang="en-US" sz="1600" b="1" dirty="0">
-                <a:solidFill>
-                  <a:schemeClr val="tx1"/>
-                </a:solidFill>
-              </a:rPr>
-              <a:t>Merge to web-app main</a:t>
-            </a:r>
-            <a:endParaRPr lang="en-US" sz="1600" dirty="0"/>
-          </a:p>
-        </p:txBody>
-      </p:sp>
-      <p:sp>
-        <p:nvSpPr>
-          <p:cNvPr id="35" name="card-140"/>
-          <p:cNvSpPr/>
-          <p:nvPr/>
-        </p:nvSpPr>
-        <p:spPr>
-          <a:xfrm>
-            <a:off x="4160520" y="4078224"/>
-            <a:ext cx="914400" cy="329184"/>
-          </a:xfrm>
-          <a:prstGeom prst="roundRect">
-            <a:avLst>
-              <a:gd name="adj" fmla="val 50000"/>
-            </a:avLst>
-          </a:prstGeom>
-          <a:solidFill>
-            <a:schemeClr val="accent1"/>
-          </a:solidFill>
-          <a:ln/>
-        </p:spPr>
-      </p:sp>
-      <p:sp>
-        <p:nvSpPr>
-          <p:cNvPr id="36" name="text-141"/>
-          <p:cNvSpPr txBox="1"/>
-          <p:nvPr/>
-        </p:nvSpPr>
-        <p:spPr>
-          <a:xfrm>
-            <a:off x="4160520" y="4078224"/>
-            <a:ext cx="914400" cy="329184"/>
-          </a:xfrm>
-          <a:prstGeom prst="rect">
-            <a:avLst/>
-          </a:prstGeom>
-          <a:noFill/>
-          <a:ln/>
-        </p:spPr>
-        <p:txBody>
-          <a:bodyPr wrap="square" lIns="0" tIns="0" rIns="0" bIns="0" rtlCol="0" anchor="ctr"/>
-          <a:lstStyle/>
-          <a:p>
-            <a:pPr algn="ctr" indent="0" marL="0">
-              <a:buNone/>
-            </a:pPr>
-            <a:r>
-              <a:rPr lang="en-US" sz="1200" b="1" dirty="0">
-                <a:solidFill>
-                  <a:schemeClr val="bg1"/>
-                </a:solidFill>
-              </a:rPr>
-              <a:t>Regular</a:t>
-            </a:r>
-            <a:endParaRPr lang="en-US" sz="1200" dirty="0"/>
-          </a:p>
-        </p:txBody>
-      </p:sp>
-      <p:sp>
-        <p:nvSpPr>
-          <p:cNvPr id="37" name="card-142"/>
-          <p:cNvSpPr/>
-          <p:nvPr/>
-        </p:nvSpPr>
-        <p:spPr>
-          <a:xfrm>
-            <a:off x="548640" y="4590288"/>
-            <a:ext cx="11091672" cy="548640"/>
-          </a:xfrm>
-          <a:prstGeom prst="roundRect">
-            <a:avLst>
-              <a:gd name="adj" fmla="val 13333"/>
-            </a:avLst>
-          </a:prstGeom>
-          <a:solidFill>
-            <a:schemeClr val="bg2"/>
-          </a:solidFill>
-          <a:ln/>
-        </p:spPr>
-      </p:sp>
-      <p:sp>
-        <p:nvSpPr>
           <p:cNvPr id="38" name="node-143"/>
           <p:cNvSpPr/>
           <p:nvPr/>
         </p:nvSpPr>
         <p:spPr>
           <a:xfrm>
-            <a:off x="713232" y="4663440"/>
+            <a:off x="713232" y="4041648"/>
             <a:ext cx="402336" cy="402336"/>
           </a:xfrm>
           <a:prstGeom prst="ellipse">
@@ -15952,7 +15792,7 @@
         </p:blipFill>
         <p:spPr>
           <a:xfrm>
-            <a:off x="813816" y="4764024"/>
+            <a:off x="813816" y="4142232"/>
             <a:ext cx="201168" cy="201168"/>
           </a:xfrm>
           <a:prstGeom prst="rect">
@@ -15968,7 +15808,7 @@
         </p:nvSpPr>
         <p:spPr>
           <a:xfrm>
-            <a:off x="1325880" y="4590288"/>
+            <a:off x="1325880" y="3968496"/>
             <a:ext cx="2743200" cy="548640"/>
           </a:xfrm>
           <a:prstGeom prst="rect">
@@ -16004,7 +15844,7 @@
         </p:nvSpPr>
         <p:spPr>
           <a:xfrm>
-            <a:off x="4160520" y="4700016"/>
+            <a:off x="4160520" y="4078224"/>
             <a:ext cx="1005840" cy="329184"/>
           </a:xfrm>
           <a:prstGeom prst="roundRect">
@@ -16031,7 +15871,7 @@
         </p:nvSpPr>
         <p:spPr>
           <a:xfrm>
-            <a:off x="4160520" y="4700016"/>
+            <a:off x="4160520" y="4078224"/>
             <a:ext cx="1005840" cy="329184"/>
           </a:xfrm>
           <a:prstGeom prst="rect">
@@ -16067,7 +15907,7 @@
         </p:nvSpPr>
         <p:spPr>
           <a:xfrm>
-            <a:off x="6675120" y="4700016"/>
+            <a:off x="6675120" y="4078224"/>
             <a:ext cx="1005840" cy="329184"/>
           </a:xfrm>
           <a:prstGeom prst="roundRect">
@@ -16094,7 +15934,7 @@
         </p:nvSpPr>
         <p:spPr>
           <a:xfrm>
-            <a:off x="6675120" y="4700016"/>
+            <a:off x="6675120" y="4078224"/>
             <a:ext cx="1005840" cy="329184"/>
           </a:xfrm>
           <a:prstGeom prst="rect">
@@ -16130,7 +15970,7 @@
         </p:nvSpPr>
         <p:spPr>
           <a:xfrm>
-            <a:off x="9189720" y="4700016"/>
+            <a:off x="9189720" y="4078224"/>
             <a:ext cx="1005840" cy="329184"/>
           </a:xfrm>
           <a:prstGeom prst="roundRect">
@@ -16157,7 +15997,7 @@
         </p:nvSpPr>
         <p:spPr>
           <a:xfrm>
-            <a:off x="9189720" y="4700016"/>
+            <a:off x="9189720" y="4078224"/>
             <a:ext cx="1005840" cy="329184"/>
           </a:xfrm>
           <a:prstGeom prst="rect">
@@ -16184,6 +16024,28 @@
             <a:endParaRPr lang="en-US" sz="1200" dirty="0"/>
           </a:p>
         </p:txBody>
+      </p:sp>
+      <p:sp>
+        <p:nvSpPr>
+          <p:cNvPr id="55" name="card-band"/>
+          <p:cNvSpPr/>
+          <p:nvPr/>
+        </p:nvSpPr>
+        <p:spPr>
+          <a:xfrm>
+            <a:off x="548640" y="4590288"/>
+            <a:ext cx="11091672" cy="548640"/>
+          </a:xfrm>
+          <a:prstGeom prst="roundRect">
+            <a:avLst>
+              <a:gd name="adj" fmla="val 13333"/>
+            </a:avLst>
+          </a:prstGeom>
+          <a:solidFill>
+            <a:schemeClr val="bg2"/>
+          </a:solidFill>
+          <a:ln/>
+        </p:spPr>
       </p:sp>
       <p:sp>
         <p:nvSpPr>
@@ -16193,7 +16055,7 @@
         </p:nvSpPr>
         <p:spPr>
           <a:xfrm>
-            <a:off x="713232" y="5285232"/>
+            <a:off x="713232" y="4663440"/>
             <a:ext cx="402336" cy="402336"/>
           </a:xfrm>
           <a:prstGeom prst="ellipse">
@@ -16221,7 +16083,7 @@
         </p:blipFill>
         <p:spPr>
           <a:xfrm>
-            <a:off x="813816" y="5385816"/>
+            <a:off x="813816" y="4764024"/>
             <a:ext cx="201168" cy="201168"/>
           </a:xfrm>
           <a:prstGeom prst="rect">
@@ -16237,7 +16099,7 @@
         </p:nvSpPr>
         <p:spPr>
           <a:xfrm>
-            <a:off x="1325880" y="5212080"/>
+            <a:off x="1325880" y="4590288"/>
             <a:ext cx="2743200" cy="548640"/>
           </a:xfrm>
           <a:prstGeom prst="rect">
@@ -16273,7 +16135,7 @@
         </p:nvSpPr>
         <p:spPr>
           <a:xfrm>
-            <a:off x="6675120" y="5321808"/>
+            <a:off x="6675120" y="4700016"/>
             <a:ext cx="1371600" cy="329184"/>
           </a:xfrm>
           <a:prstGeom prst="roundRect">
@@ -16295,7 +16157,7 @@
         </p:nvSpPr>
         <p:spPr>
           <a:xfrm>
-            <a:off x="6675120" y="5321808"/>
+            <a:off x="6675120" y="4700016"/>
             <a:ext cx="1371600" cy="329184"/>
           </a:xfrm>
           <a:prstGeom prst="rect">
@@ -16331,7 +16193,7 @@
         </p:nvSpPr>
         <p:spPr>
           <a:xfrm>
-            <a:off x="9189720" y="5321808"/>
+            <a:off x="9189720" y="4700016"/>
             <a:ext cx="1371600" cy="329184"/>
           </a:xfrm>
           <a:prstGeom prst="roundRect">
@@ -16353,7 +16215,7 @@
         </p:nvSpPr>
         <p:spPr>
           <a:xfrm>
-            <a:off x="9189720" y="5321808"/>
+            <a:off x="9189720" y="4700016"/>
             <a:ext cx="1371600" cy="329184"/>
           </a:xfrm>
           <a:prstGeom prst="rect">
@@ -16389,7 +16251,7 @@
         </p:nvSpPr>
         <p:spPr>
           <a:xfrm>
-            <a:off x="548640" y="5870448"/>
+            <a:off x="548640" y="5440680"/>
             <a:ext cx="10972800" cy="320040"/>
           </a:xfrm>
           <a:prstGeom prst="rect">

</xml_diff>